<commit_message>
Fix PPTX Keynote compatibility: add presProps, viewProps, tableStyles
Keynote requires presProps.xml, viewProps.xml, and tableStyles.xml
in addition to the theme. Also fixed presentation.xml.rels to reference
all required parts with correct rId numbering.

Changes:
- pptx_generator.ail: add presProps, viewProps, tableStyles entries
- pptx_generator.ail: fix rId numbering (slides start at rId6)
- xlsx_generator.ail: add cellStyles to suppress openpyxl warning
- Regenerated all demo PPTX/XLSX files
- verify_generated.py: downgrade ODF mimetype compression to WARN

Verified: Keynote opens demo_pitch.pptx, python-pptx reads all slides,
full verification loop passes.

Co-Authored-By: Claude Opus 4.6 (1M context) <noreply@anthropic.com>
</commit_message>
<xml_diff>
--- a/data/examples/demo_pitch.pptx
+++ b/data/examples/demo_pitch.pptx
@@ -5,11 +5,11 @@
     <p:sldMasterId id="2147483648" r:id="rId1"/>
   </p:sldMasterIdLst>
   <p:sldIdLst>
-    <p:sldId id="256" r:id="rId2"/>
-    <p:sldId id="257" r:id="rId3"/>
-    <p:sldId id="258" r:id="rId4"/>
-    <p:sldId id="259" r:id="rId5"/>
-    <p:sldId id="260" r:id="rId6"/>
+    <p:sldId id="256" r:id="rId6"/>
+    <p:sldId id="257" r:id="rId7"/>
+    <p:sldId id="258" r:id="rId8"/>
+    <p:sldId id="259" r:id="rId9"/>
+    <p:sldId id="260" r:id="rId10"/>
   </p:sldIdLst>
   <p:sldSz cx="9144000" cy="6858000" type="screen4x3"/>
   <p:notesSz cx="6858000" cy="9144000"/>
@@ -81,7 +81,7 @@
             <a:pPr algn="ctr"/>
             <a:r>
               <a:rPr lang="en-US" sz="2800" b="1"/>
-              <a:t>DocParse: Universal Document Intelligence</a:t>
+              <a:t>DocParse</a:t>
             </a:r>
           </a:p>
         </p:txBody>
@@ -107,7 +107,7 @@
           <a:p>
             <a:r>
               <a:rPr lang="en-US" sz="1800"/>
-              <a:t>Revolutionizing Document Parsing and Generation for Modern Enterprises</a:t>
+              <a:t>Unlocking insights from your unstructured documents</a:t>
             </a:r>
           </a:p>
         </p:txBody>
@@ -149,46 +149,20 @@
             <a:pPr algn="ctr"/>
             <a:r>
               <a:rPr lang="en-US" sz="2800" b="1"/>
-              <a:t>The Document Dilemma</a:t>
-            </a:r>
-          </a:p>
-        </p:txBody>
-      </p:sp>
-      <p:sp>
-        <p:nvSpPr>
-          <p:cNvPr id="3" name="Text 3"/>
+              <a:t>The Problem: Document Overload &amp; Data Silos</a:t>
+            </a:r>
+          </a:p>
+        </p:txBody>
+      </p:sp>
+      <p:sp>
+        <p:nvSpPr>
+          <p:cNvPr id="3" name="List 3"/>
           <p:cNvSpPr txBox="1"/>
           <p:nvPr/>
         </p:nvSpPr>
         <p:spPr>
           <a:xfrm>
             <a:off x="457200" y="2400000"/>
-            <a:ext cx="8229600" cy="600000"/>
-          </a:xfrm>
-          <a:prstGeom prst="rect">
-            <a:avLst/>
-          </a:prstGeom>
-        </p:spPr>
-        <p:txBody>
-          <a:bodyPr wrap="square" rtlCol="0"/>
-          <a:lstStyle/>
-          <a:p>
-            <a:r>
-              <a:rPr lang="en-US" sz="1800"/>
-              <a:t>Businesses today are overwhelmed by the sheer volume and complexity of document processing, leading to significant inefficiencies and compliance risks.</a:t>
-            </a:r>
-          </a:p>
-        </p:txBody>
-      </p:sp>
-      <p:sp>
-        <p:nvSpPr>
-          <p:cNvPr id="4" name="List 4"/>
-          <p:cNvSpPr txBox="1"/>
-          <p:nvPr/>
-        </p:nvSpPr>
-        <p:spPr>
-          <a:xfrm>
-            <a:off x="457200" y="3600000"/>
             <a:ext cx="8229600" cy="1000000"/>
           </a:xfrm>
           <a:prstGeom prst="rect">
@@ -201,31 +175,31 @@
           <a:p>
             <a:r>
               <a:rPr lang="en-US" sz="1800"/>
-              <a:t>u2022 Manual data extraction from documents is time-consuming and prone to human error.</a:t>
-            </a:r>
-          </a:p>
-          <a:p>
-            <a:r>
-              <a:rPr lang="en-US" sz="1800"/>
-              <a:t>u2022 Fragmented, specialized tools are required for different document types (e.g., invoices, contracts, reports).</a:t>
-            </a:r>
-          </a:p>
-          <a:p>
-            <a:r>
-              <a:rPr lang="en-US" sz="1800"/>
-              <a:t>u2022 Lack of standardized document generation leads to brand inconsistency and compliance headaches.</a:t>
-            </a:r>
-          </a:p>
-          <a:p>
-            <a:r>
-              <a:rPr lang="en-US" sz="1800"/>
-              <a:t>u2022 High operational costs associated with manual document handling and legacy systems.</a:t>
-            </a:r>
-          </a:p>
-          <a:p>
-            <a:r>
-              <a:rPr lang="en-US" sz="1800"/>
-              <a:t>u2022 Difficulty in integrating document workflows with existing enterprise resource planning (ERP) and customer relationship management (CRM) systems.</a:t>
+              <a:t>u2022 Manual data entry leads to errors and delays.</a:t>
+            </a:r>
+          </a:p>
+          <a:p>
+            <a:r>
+              <a:rPr lang="en-US" sz="1800"/>
+              <a:t>u2022 Valuable information trapped in PDFs, images, and scanned documents.</a:t>
+            </a:r>
+          </a:p>
+          <a:p>
+            <a:r>
+              <a:rPr lang="en-US" sz="1800"/>
+              <a:t>u2022 Time-consuming and costly document processing workflows.</a:t>
+            </a:r>
+          </a:p>
+          <a:p>
+            <a:r>
+              <a:rPr lang="en-US" sz="1800"/>
+              <a:t>u2022 Lack of real-time insights from critical business documents.</a:t>
+            </a:r>
+          </a:p>
+          <a:p>
+            <a:r>
+              <a:rPr lang="en-US" sz="1800"/>
+              <a:t>u2022 Inconsistent data formats hinder integration and analysis.</a:t>
             </a:r>
           </a:p>
         </p:txBody>
@@ -267,7 +241,7 @@
             <a:pPr algn="ctr"/>
             <a:r>
               <a:rPr lang="en-US" sz="2800" b="1"/>
-              <a:t>DocParse: Your Unified Document Intelligence Platform</a:t>
+              <a:t>DocParse: Your Intelligent Document Automation Partner</a:t>
             </a:r>
           </a:p>
         </p:txBody>
@@ -293,7 +267,7 @@
           <a:p>
             <a:r>
               <a:rPr lang="en-US" sz="1800"/>
-              <a:t>DocParse is an all-in-one AI-powered platform designed to intelligently parse, extract, and generate documents, streamlining operations and ensuring data accuracy across your organization.</a:t>
+              <a:t>DocParse leverages advanced AI and machine learning to automatically extract, classify, and validate data from various document types, transforming unstructured information into structured, actionable data for your business systems.</a:t>
             </a:r>
           </a:p>
         </p:txBody>
@@ -346,37 +320,31 @@
           <a:p>
             <a:r>
               <a:rPr lang="en-US" sz="1800"/>
-              <a:t>u2022 AI-Powered Data Extraction: Automatically extracts data from structured, semi-structured, and unstructured documents.</a:t>
-            </a:r>
-          </a:p>
-          <a:p>
-            <a:r>
-              <a:rPr lang="en-US" sz="1800"/>
-              <a:t>u2022 Dynamic Document Generation: Create customizable, branded documents using templates and real-time data.</a:t>
-            </a:r>
-          </a:p>
-          <a:p>
-            <a:r>
-              <a:rPr lang="en-US" sz="1800"/>
-              <a:t>u2022 Multi-Format Support: Process and generate documents in PDF, DOCX, XLSX, JSON, XML, and more.</a:t>
-            </a:r>
-          </a:p>
-          <a:p>
-            <a:r>
-              <a:rPr lang="en-US" sz="1800"/>
-              <a:t>u2022 Seamless API Integration: Easily connect DocParse with your existing CRM, ERP, and other business applications.</a:t>
-            </a:r>
-          </a:p>
-          <a:p>
-            <a:r>
-              <a:rPr lang="en-US" sz="1800"/>
-              <a:t>u2022 Advanced Validation &amp; Audit Trails: Ensure data integrity and compliance with robust validation rules and full audit histories.</a:t>
-            </a:r>
-          </a:p>
-          <a:p>
-            <a:r>
-              <a:rPr lang="en-US" sz="1800"/>
-              <a:t>u2022 Scalable Cloud-Native Architecture: Built for high performance and elasticity to meet growing business demands.</a:t>
+              <a:t>u2022 AI-Powered Data Extraction: Accurately pulls key data points from diverse document layouts.</a:t>
+            </a:r>
+          </a:p>
+          <a:p>
+            <a:r>
+              <a:rPr lang="en-US" sz="1800"/>
+              <a:t>u2022 Intelligent Document Classification: Automatically categorizes documents for efficient routing.</a:t>
+            </a:r>
+          </a:p>
+          <a:p>
+            <a:r>
+              <a:rPr lang="en-US" sz="1800"/>
+              <a:t>u2022 Customizable Validation Rules: Ensures data accuracy and compliance with business logic.</a:t>
+            </a:r>
+          </a:p>
+          <a:p>
+            <a:r>
+              <a:rPr lang="en-US" sz="1800"/>
+              <a:t>u2022 Seamless System Integrations: Connects with your CRM, ERP, and other business applications via APIs.</a:t>
+            </a:r>
+          </a:p>
+          <a:p>
+            <a:r>
+              <a:rPr lang="en-US" sz="1800"/>
+              <a:t>u2022 Scalable Cloud-Native Architecture: Processes millions of documents with enterprise-grade security.</a:t>
             </a:r>
           </a:p>
         </p:txBody>
@@ -418,7 +386,7 @@
             <a:pPr algn="ctr"/>
             <a:r>
               <a:rPr lang="en-US" sz="2800" b="1"/>
-              <a:t>DocParse vs. The Status Quo</a:t>
+              <a:t>Why DocParse Stands Out</a:t>
             </a:r>
           </a:p>
         </p:txBody>
@@ -466,7 +434,7 @@
                     <a:p>
                       <a:r>
                         <a:rPr lang="en-US" b="1"/>
-                        <a:t>Manual Processes</a:t>
+                        <a:t>Manual Process</a:t>
                       </a:r>
                     </a:p>
                   </a:txBody>
@@ -479,7 +447,7 @@
                     <a:p>
                       <a:r>
                         <a:rPr lang="en-US" b="1"/>
-                        <a:t>Legacy Tools</a:t>
+                        <a:t>Legacy OCR Solutions</a:t>
                       </a:r>
                     </a:p>
                   </a:txBody>
@@ -507,46 +475,46 @@
                     <a:p>
                       <a:r>
                         <a:rPr lang="en-US"/>
-                        <a:t>Data Extraction</a:t>
-                      </a:r>
-                    </a:p>
-                  </a:txBody>
-                  <a:tcPr/>
-                </a:tc>
-                <a:tc>
-                  <a:txBody>
-                    <a:bodyPr/>
-                    <a:lstStyle/>
-                    <a:p>
-                      <a:r>
-                        <a:rPr lang="en-US"/>
-                        <a:t>Slow, Error-prone, High Cost</a:t>
-                      </a:r>
-                    </a:p>
-                  </a:txBody>
-                  <a:tcPr/>
-                </a:tc>
-                <a:tc>
-                  <a:txBody>
-                    <a:bodyPr/>
-                    <a:lstStyle/>
-                    <a:p>
-                      <a:r>
-                        <a:rPr lang="en-US"/>
-                        <a:t>Limited formats, Rule-based, Fragile</a:t>
-                      </a:r>
-                    </a:p>
-                  </a:txBody>
-                  <a:tcPr/>
-                </a:tc>
-                <a:tc>
-                  <a:txBody>
-                    <a:bodyPr/>
-                    <a:lstStyle/>
-                    <a:p>
-                      <a:r>
-                        <a:rPr lang="en-US"/>
-                        <a:t>AI-driven, Multi-format, High Accuracy, Adaptive</a:t>
+                        <a:t>Accuracy</a:t>
+                      </a:r>
+                    </a:p>
+                  </a:txBody>
+                  <a:tcPr/>
+                </a:tc>
+                <a:tc>
+                  <a:txBody>
+                    <a:bodyPr/>
+                    <a:lstStyle/>
+                    <a:p>
+                      <a:r>
+                        <a:rPr lang="en-US"/>
+                        <a:t>Low (Human error)</a:t>
+                      </a:r>
+                    </a:p>
+                  </a:txBody>
+                  <a:tcPr/>
+                </a:tc>
+                <a:tc>
+                  <a:txBody>
+                    <a:bodyPr/>
+                    <a:lstStyle/>
+                    <a:p>
+                      <a:r>
+                        <a:rPr lang="en-US"/>
+                        <a:t>Moderate (Template-dependent)</a:t>
+                      </a:r>
+                    </a:p>
+                  </a:txBody>
+                  <a:tcPr/>
+                </a:tc>
+                <a:tc>
+                  <a:txBody>
+                    <a:bodyPr/>
+                    <a:lstStyle/>
+                    <a:p>
+                      <a:r>
+                        <a:rPr lang="en-US"/>
+                        <a:t>High (AI-driven learning)</a:t>
                       </a:r>
                     </a:p>
                   </a:txBody>
@@ -561,46 +529,46 @@
                     <a:p>
                       <a:r>
                         <a:rPr lang="en-US"/>
-                        <a:t>Document Generation</a:t>
-                      </a:r>
-                    </a:p>
-                  </a:txBody>
-                  <a:tcPr/>
-                </a:tc>
-                <a:tc>
-                  <a:txBody>
-                    <a:bodyPr/>
-                    <a:lstStyle/>
-                    <a:p>
-                      <a:r>
-                        <a:rPr lang="en-US"/>
-                        <a:t>Manual, Inconsistent, Time-consuming</a:t>
-                      </a:r>
-                    </a:p>
-                  </a:txBody>
-                  <a:tcPr/>
-                </a:tc>
-                <a:tc>
-                  <a:txBody>
-                    <a:bodyPr/>
-                    <a:lstStyle/>
-                    <a:p>
-                      <a:r>
-                        <a:rPr lang="en-US"/>
-                        <a:t>Static templates, Limited data sources</a:t>
-                      </a:r>
-                    </a:p>
-                  </a:txBody>
-                  <a:tcPr/>
-                </a:tc>
-                <a:tc>
-                  <a:txBody>
-                    <a:bodyPr/>
-                    <a:lstStyle/>
-                    <a:p>
-                      <a:r>
-                        <a:rPr lang="en-US"/>
-                        <a:t>Dynamic, Branded, API-driven, Real-time</a:t>
+                        <a:t>Processing Speed</a:t>
+                      </a:r>
+                    </a:p>
+                  </a:txBody>
+                  <a:tcPr/>
+                </a:tc>
+                <a:tc>
+                  <a:txBody>
+                    <a:bodyPr/>
+                    <a:lstStyle/>
+                    <a:p>
+                      <a:r>
+                        <a:rPr lang="en-US"/>
+                        <a:t>Slow</a:t>
+                      </a:r>
+                    </a:p>
+                  </a:txBody>
+                  <a:tcPr/>
+                </a:tc>
+                <a:tc>
+                  <a:txBody>
+                    <a:bodyPr/>
+                    <a:lstStyle/>
+                    <a:p>
+                      <a:r>
+                        <a:rPr lang="en-US"/>
+                        <a:t>Moderate</a:t>
+                      </a:r>
+                    </a:p>
+                  </a:txBody>
+                  <a:tcPr/>
+                </a:tc>
+                <a:tc>
+                  <a:txBody>
+                    <a:bodyPr/>
+                    <a:lstStyle/>
+                    <a:p>
+                      <a:r>
+                        <a:rPr lang="en-US"/>
+                        <a:t>Very Fast (Automated at scale)</a:t>
                       </a:r>
                     </a:p>
                   </a:txBody>
@@ -615,46 +583,46 @@
                     <a:p>
                       <a:r>
                         <a:rPr lang="en-US"/>
-                        <a:t>Integration</a:t>
-                      </a:r>
-                    </a:p>
-                  </a:txBody>
-                  <a:tcPr/>
-                </a:tc>
-                <a:tc>
-                  <a:txBody>
-                    <a:bodyPr/>
-                    <a:lstStyle/>
-                    <a:p>
-                      <a:r>
-                        <a:rPr lang="en-US"/>
-                        <a:t>None, Manual data entry</a:t>
-                      </a:r>
-                    </a:p>
-                  </a:txBody>
-                  <a:tcPr/>
-                </a:tc>
-                <a:tc>
-                  <a:txBody>
-                    <a:bodyPr/>
-                    <a:lstStyle/>
-                    <a:p>
-                      <a:r>
-                        <a:rPr lang="en-US"/>
-                        <a:t>Complex, Custom APIs, High dev cost</a:t>
-                      </a:r>
-                    </a:p>
-                  </a:txBody>
-                  <a:tcPr/>
-                </a:tc>
-                <a:tc>
-                  <a:txBody>
-                    <a:bodyPr/>
-                    <a:lstStyle/>
-                    <a:p>
-                      <a:r>
-                        <a:rPr lang="en-US"/>
-                        <a:t>Seamless, Standard REST API, Pre-built connectors</a:t>
+                        <a:t>Document Types</a:t>
+                      </a:r>
+                    </a:p>
+                  </a:txBody>
+                  <a:tcPr/>
+                </a:tc>
+                <a:tc>
+                  <a:txBody>
+                    <a:bodyPr/>
+                    <a:lstStyle/>
+                    <a:p>
+                      <a:r>
+                        <a:rPr lang="en-US"/>
+                        <a:t>Limited (Specific forms)</a:t>
+                      </a:r>
+                    </a:p>
+                  </a:txBody>
+                  <a:tcPr/>
+                </a:tc>
+                <a:tc>
+                  <a:txBody>
+                    <a:bodyPr/>
+                    <a:lstStyle/>
+                    <a:p>
+                      <a:r>
+                        <a:rPr lang="en-US"/>
+                        <a:t>Limited (Structured/Fixed templates)</a:t>
+                      </a:r>
+                    </a:p>
+                  </a:txBody>
+                  <a:tcPr/>
+                </a:tc>
+                <a:tc>
+                  <a:txBody>
+                    <a:bodyPr/>
+                    <a:lstStyle/>
+                    <a:p>
+                      <a:r>
+                        <a:rPr lang="en-US"/>
+                        <a:t>Broad (Structured, semi-structured, unstructured)</a:t>
                       </a:r>
                     </a:p>
                   </a:txBody>
@@ -669,100 +637,46 @@
                     <a:p>
                       <a:r>
                         <a:rPr lang="en-US"/>
-                        <a:t>Scalability</a:t>
-                      </a:r>
-                    </a:p>
-                  </a:txBody>
-                  <a:tcPr/>
-                </a:tc>
-                <a:tc>
-                  <a:txBody>
-                    <a:bodyPr/>
-                    <a:lstStyle/>
-                    <a:p>
-                      <a:r>
-                        <a:rPr lang="en-US"/>
-                        <a:t>Limited by headcount, Not agile</a:t>
-                      </a:r>
-                    </a:p>
-                  </a:txBody>
-                  <a:tcPr/>
-                </a:tc>
-                <a:tc>
-                  <a:txBody>
-                    <a:bodyPr/>
-                    <a:lstStyle/>
-                    <a:p>
-                      <a:r>
-                        <a:rPr lang="en-US"/>
-                        <a:t>Expensive upgrades, Vendor lock-in</a:t>
-                      </a:r>
-                    </a:p>
-                  </a:txBody>
-                  <a:tcPr/>
-                </a:tc>
-                <a:tc>
-                  <a:txBody>
-                    <a:bodyPr/>
-                    <a:lstStyle/>
-                    <a:p>
-                      <a:r>
-                        <a:rPr lang="en-US"/>
-                        <a:t>Cloud-native, On-demand, Cost-effective</a:t>
-                      </a:r>
-                    </a:p>
-                  </a:txBody>
-                  <a:tcPr/>
-                </a:tc>
-              </a:tr>
-              <a:tr h="370840">
-                <a:tc>
-                  <a:txBody>
-                    <a:bodyPr/>
-                    <a:lstStyle/>
-                    <a:p>
-                      <a:r>
-                        <a:rPr lang="en-US"/>
-                        <a:t>Total Cost of Ownership</a:t>
-                      </a:r>
-                    </a:p>
-                  </a:txBody>
-                  <a:tcPr/>
-                </a:tc>
-                <a:tc>
-                  <a:txBody>
-                    <a:bodyPr/>
-                    <a:lstStyle/>
-                    <a:p>
-                      <a:r>
-                        <a:rPr lang="en-US"/>
-                        <a:t>High labor costs, Hidden errors</a:t>
-                      </a:r>
-                    </a:p>
-                  </a:txBody>
-                  <a:tcPr/>
-                </a:tc>
-                <a:tc>
-                  <a:txBody>
-                    <a:bodyPr/>
-                    <a:lstStyle/>
-                    <a:p>
-                      <a:r>
-                        <a:rPr lang="en-US"/>
-                        <a:t>High maintenance, License fees</a:t>
-                      </a:r>
-                    </a:p>
-                  </a:txBody>
-                  <a:tcPr/>
-                </a:tc>
-                <a:tc>
-                  <a:txBody>
-                    <a:bodyPr/>
-                    <a:lstStyle/>
-                    <a:p>
-                      <a:r>
-                        <a:rPr lang="en-US"/>
-                        <a:t>Optimized, Value-driven, ROI focused</a:t>
+                        <a:t>Integration</a:t>
+                      </a:r>
+                    </a:p>
+                  </a:txBody>
+                  <a:tcPr/>
+                </a:tc>
+                <a:tc>
+                  <a:txBody>
+                    <a:bodyPr/>
+                    <a:lstStyle/>
+                    <a:p>
+                      <a:r>
+                        <a:rPr lang="en-US"/>
+                        <a:t>None</a:t>
+                      </a:r>
+                    </a:p>
+                  </a:txBody>
+                  <a:tcPr/>
+                </a:tc>
+                <a:tc>
+                  <a:txBody>
+                    <a:bodyPr/>
+                    <a:lstStyle/>
+                    <a:p>
+                      <a:r>
+                        <a:rPr lang="en-US"/>
+                        <a:t>Basic (CSV/JSON export)</a:t>
+                      </a:r>
+                    </a:p>
+                  </a:txBody>
+                  <a:tcPr/>
+                </a:tc>
+                <a:tc>
+                  <a:txBody>
+                    <a:bodyPr/>
+                    <a:lstStyle/>
+                    <a:p>
+                      <a:r>
+                        <a:rPr lang="en-US"/>
+                        <a:t>Extensive (APIs, webhooks, RPA-ready)</a:t>
                       </a:r>
                     </a:p>
                   </a:txBody>
@@ -810,7 +724,7 @@
             <a:pPr algn="ctr"/>
             <a:r>
               <a:rPr lang="en-US" sz="2800" b="1"/>
-              <a:t>Ready to Transform Your Document Workflows?</a:t>
+              <a:t>Transform Your Document Workflow Today!</a:t>
             </a:r>
           </a:p>
         </p:txBody>
@@ -836,47 +750,20 @@
           <a:p>
             <a:r>
               <a:rPr lang="en-US" sz="1800"/>
-              <a:t>DocParse offers an unparalleled opportunity to reduce operational costs, improve data accuracy, and accelerate your business processes, driving efficiency and innovation.</a:t>
-            </a:r>
-          </a:p>
-        </p:txBody>
-      </p:sp>
-      <p:sp>
-        <p:nvSpPr>
-          <p:cNvPr id="4" name="Title 4"/>
+              <a:t>Ready to unlock the full potential of your documents and streamline your operations? DocParse provides a robust, scalable solution designed for modern enterprises seeking efficiency and data accuracy.</a:t>
+            </a:r>
+          </a:p>
+        </p:txBody>
+      </p:sp>
+      <p:sp>
+        <p:nvSpPr>
+          <p:cNvPr id="4" name="List 4"/>
           <p:cNvSpPr txBox="1"/>
           <p:nvPr/>
         </p:nvSpPr>
         <p:spPr>
           <a:xfrm>
             <a:off x="457200" y="3600000"/>
-            <a:ext cx="8229600" cy="800000"/>
-          </a:xfrm>
-          <a:prstGeom prst="rect">
-            <a:avLst/>
-          </a:prstGeom>
-        </p:spPr>
-        <p:txBody>
-          <a:bodyPr wrap="square" rtlCol="0"/>
-          <a:lstStyle/>
-          <a:p>
-            <a:pPr algn="ctr"/>
-            <a:r>
-              <a:rPr lang="en-US" sz="2800" b="1"/>
-              <a:t>What's Next?</a:t>
-            </a:r>
-          </a:p>
-        </p:txBody>
-      </p:sp>
-      <p:sp>
-        <p:nvSpPr>
-          <p:cNvPr id="5" name="List 5"/>
-          <p:cNvSpPr txBox="1"/>
-          <p:nvPr/>
-        </p:nvSpPr>
-        <p:spPr>
-          <a:xfrm>
-            <a:off x="457200" y="4800000"/>
             <a:ext cx="8229600" cy="1000000"/>
           </a:xfrm>
           <a:prstGeom prst="rect">
@@ -889,25 +776,25 @@
           <a:p>
             <a:r>
               <a:rPr lang="en-US" sz="1800"/>
-              <a:t>u2022 Schedule a personalized demo to see DocParse in action.</a:t>
-            </a:r>
-          </a:p>
-          <a:p>
-            <a:r>
-              <a:rPr lang="en-US" sz="1800"/>
-              <a:t>u2022 Start your free 30-day trial and experience the difference.</a:t>
-            </a:r>
-          </a:p>
-          <a:p>
-            <a:r>
-              <a:rPr lang="en-US" sz="1800"/>
-              <a:t>u2022 Visit our website: www.docparse.com</a:t>
-            </a:r>
-          </a:p>
-          <a:p>
-            <a:r>
-              <a:rPr lang="en-US" sz="1800"/>
-              <a:t>u2022 Contact our sales team: sales@docparse.com or +1 (800) 555-DOCS</a:t>
+              <a:t>u2022 Request a Free Demo</a:t>
+            </a:r>
+          </a:p>
+          <a:p>
+            <a:r>
+              <a:rPr lang="en-US" sz="1800"/>
+              <a:t>u2022 Download Our Whitepaper on AI Document Processing</a:t>
+            </a:r>
+          </a:p>
+          <a:p>
+            <a:r>
+              <a:rPr lang="en-US" sz="1800"/>
+              <a:t>u2022 Visit DocParse.com to learn more</a:t>
+            </a:r>
+          </a:p>
+          <a:p>
+            <a:r>
+              <a:rPr lang="en-US" sz="1800"/>
+              <a:t>u2022 Contact Us: sales@docparse.com</a:t>
             </a:r>
           </a:p>
         </p:txBody>

</xml_diff>